<commit_message>
Seminar p05: sync with the user's final novelty table
After checking each paper against its original, the user's slide now
reads: Miara 2015 | one cation, 3 sites (Li, La, Zr) | 128 (45 was
Anderson's citation, so "via Anderson" and the Anderson reference are
gone); Xiao "(coating layer)"; Lee "P-site cations and halides";
bullet 1 "Earlier screens varied elements, ..."; bullet 2 "adds its
cation and anion together, in its formula ratio." Both decks are
rebuilt (validate passes) with the same corrections; the full deck's
older bullets ("one element on a site", "one cation and one anion
site") are replaced too. The script drops the Anderson sentence that
no longer has a reference on screen; defense and open items record
the decision. Numbers keep thousands separators in our copy.

Co-Authored-By: Claude Opus 5.5 <noreply@anthropic.com>
Claude-Session: https://claude.ai/code/session_01QtbBQvJTvwH5CtkzA6CTzs
</commit_message>
<xml_diff>
--- a/kb/seminars/Research_Seminar_2026_10_13_cascade_progress.pptx
+++ b/kb/seminars/Research_Seminar_2026_10_13_cascade_progress.pptx
@@ -18259,7 +18259,7 @@
                           <a:ea typeface="+mn-ea"/>
                           <a:cs typeface="Calibri" panose="020F0502020204030204" pitchFamily="34" charset="0"/>
                         </a:rPr>
-                        <a:t>Miara 2015 (via Anderson)</a:t>
+                        <a:t>Miara 2015</a:t>
                       </a:r>
                     </a:p>
                   </a:txBody>
@@ -18387,7 +18387,7 @@
                           <a:ea typeface="+mn-ea"/>
                           <a:cs typeface="Calibri" panose="020F0502020204030204" pitchFamily="34" charset="0"/>
                         </a:rPr>
-                        <a:t>one cation, 3 sites</a:t>
+                        <a:t>one cation, 3 sites (Li, La, Zr)</a:t>
                       </a:r>
                     </a:p>
                   </a:txBody>
@@ -18457,7 +18457,7 @@
                           <a:ea typeface="+mn-ea"/>
                           <a:cs typeface="Calibri" panose="020F0502020204030204" pitchFamily="34" charset="0"/>
                         </a:rPr>
-                        <a:t>45</a:t>
+                        <a:t>128</a:t>
                       </a:r>
                     </a:p>
                   </a:txBody>
@@ -18732,7 +18732,7 @@
                           <a:ea typeface="+mn-ea"/>
                           <a:cs typeface="Calibri" panose="020F0502020204030204" pitchFamily="34" charset="0"/>
                         </a:rPr>
-                        <a:t>elements already in the formula</a:t>
+                        <a:t>P-site cations and halides</a:t>
                       </a:r>
                     </a:p>
                   </a:txBody>
@@ -19018,7 +19018,7 @@
                           <a:ea typeface="+mn-ea"/>
                           <a:cs typeface="Calibri" panose="020F0502020204030204" pitchFamily="34" charset="0"/>
                         </a:rPr>
-                        <a:t> — free coating</a:t>
+                        <a:t> — coating layer</a:t>
                       </a:r>
                     </a:p>
                   </a:txBody>
@@ -19778,7 +19778,7 @@
                 <a:ea typeface="-윤고딕340" pitchFamily="18" charset="-127"/>
                 <a:cs typeface="Calibri" panose="020F0502020204030204" pitchFamily="34" charset="0"/>
               </a:rPr>
-              <a:t>Earlier screens place one element on a site, or screen hostless compounds.</a:t>
+              <a:t>Earlier screens varied elements, or a coating compound without a host.</a:t>
             </a:r>
           </a:p>
           <a:p>
@@ -19803,7 +19803,7 @@
                 <a:ea typeface="-윤고딕340" pitchFamily="18" charset="-127"/>
                 <a:cs typeface="Calibri" panose="020F0502020204030204" pitchFamily="34" charset="0"/>
               </a:rPr>
-              <a:t>Here a </a:t>
+              <a:t>Here one </a:t>
             </a:r>
             <a:r>
               <a:rPr kumimoji="1" lang="en-US" altLang="ko-KR" sz="1500" dirty="0">
@@ -19825,7 +19825,7 @@
                 <a:ea typeface="-윤고딕340" pitchFamily="18" charset="-127"/>
                 <a:cs typeface="Calibri" panose="020F0502020204030204" pitchFamily="34" charset="0"/>
               </a:rPr>
-              <a:t> fills one cation and one anion site at once.</a:t>
+              <a:t> adds its cation and anion together, in its formula ratio.</a:t>
             </a:r>
           </a:p>
         </p:txBody>
@@ -19868,7 +19868,7 @@
                 <a:ea typeface="-윤고딕340" pitchFamily="18" charset="-127"/>
                 <a:cs typeface="Calibri" panose="020F0502020204030204" pitchFamily="34" charset="0"/>
               </a:rPr>
-              <a:t>Chem. Mater. 27, 4040 (2015) · Adv. Energy Mater. 14, 2304025 (2024)</a:t>
+              <a:t>Chem. Mater. 27, 4040 (2015) · Joule 3, 1252 (2019)</a:t>
             </a:r>
           </a:p>
           <a:p>
@@ -19888,7 +19888,7 @@
                 <a:ea typeface="-윤고딕340" pitchFamily="18" charset="-127"/>
                 <a:cs typeface="Calibri" panose="020F0502020204030204" pitchFamily="34" charset="0"/>
               </a:rPr>
-              <a:t>J. Mater. Chem. A 12, 7272 (2024) · Joule 3, 1252 (2019)</a:t>
+              <a:t>J. Mater. Chem. A 12, 7272 (2024)</a:t>
             </a:r>
           </a:p>
         </p:txBody>

</xml_diff>

<commit_message>
Seminar: no "gate" on the slides; Jung 2026 briefing
User 10-13: avoid words like "gate". The novelty table's mechanical
column now reads "ML-predicted G and G/K (used for screening)" for
Jung 2026 (Fig. 2a: G > 8.4 GPa and G/K < 0.7 cut 987 to 873) and
"DFT reference + MLIP descriptor (not used for screening)" for this
work, each parenthesis on its own line (new two_lines helper; the
study column gave 0.5 in to the mechanical one). The p07 bar labelled
"gate funnel" is now "literature thresholds" (CSV label follows).
Both decks rebuilt and validated; p05/p07 renders and contact sheet
updated. Defense S5 Jung entry checked against Fig. 2 (2,550 is not
40 x 4 x 9), and CLAUDE.md records the wording rule.

Co-Authored-By: Claude Opus 5.5 <noreply@anthropic.com>
Claude-Session: https://claude.ai/code/session_01QtbBQvJTvwH5CtkzA6CTzs
</commit_message>
<xml_diff>
--- a/kb/seminars/Research_Seminar_2026_10_13_cascade_progress.pptx
+++ b/kb/seminars/Research_Seminar_2026_10_13_cascade_progress.pptx
@@ -19614,7 +19614,7 @@
                           <a:ea typeface="+mn-ea"/>
                           <a:cs typeface="Calibri" panose="020F0502020204030204" pitchFamily="34" charset="0"/>
                         </a:rPr>
-                        <a:t>DFT reference + MLIP descriptor (not a gate)</a:t>
+                        <a:t>DFT reference + MLIP descriptor</a:t>
                       </a:r>
                       <a:br>
                         <a:rPr lang="en-US" sz="1050" kern="1200" dirty="0">
@@ -19626,7 +19626,7 @@
                           <a:cs typeface="Calibri" panose="020F0502020204030204" pitchFamily="34" charset="0"/>
                         </a:rPr>
                       </a:br>
-                      <a:br>
+                      <a:r>
                         <a:rPr lang="en-US" sz="1050" kern="1200" dirty="0">
                           <a:solidFill>
                             <a:srgbClr val="0070C0"/>
@@ -19635,7 +19635,8 @@
                           <a:ea typeface="+mn-ea"/>
                           <a:cs typeface="Calibri" panose="020F0502020204030204" pitchFamily="34" charset="0"/>
                         </a:rPr>
-                      </a:br>
+                        <a:t>(not used for screening)</a:t>
+                      </a:r>
                       <a:endParaRPr sz="1050" kern="1200" dirty="0">
                         <a:solidFill>
                           <a:srgbClr val="0070C0"/>

</xml_diff>

<commit_message>
Seminar p06: back to the 08-18 family table, third column "anion vs. host"
User 10-13: replace the bar-chart page with the 08-18 Candidate set
slide and rewrite only its role column and bullets for the story. The
column now compares each family's anion with the host's S2- and Cl-
(set_anion_column, eight rows asserted); the bullets say every
precursor is an existing compound (cations +1 to +6) and that Al, Li
and Mg appear in all seven families (counted from the 91-precursor
ledger), which leads back to the p03 Al2O3-versus-Al2S3 question. The
SiO2 literature crop leaves the slide (co-doping papers stay on p17).
The full deck gets the same table, header and bullets. Script,
storyline, defense (new-column questions) and the CSV README follow.

Co-Authored-By: Claude Opus 5.5 <noreply@anthropic.com>
Claude-Session: https://claude.ai/code/session_01QtbBQvJTvwH5CtkzA6CTzs
</commit_message>
<xml_diff>
--- a/kb/seminars/Research_Seminar_2026_10_13_cascade_progress.pptx
+++ b/kb/seminars/Research_Seminar_2026_10_13_cascade_progress.pptx
@@ -20362,7 +20362,7 @@
                           <a:ea typeface="Calibri" panose="020F0502020204030204" pitchFamily="34" charset="0"/>
                           <a:cs typeface="Calibri" panose="020F0502020204030204" pitchFamily="34" charset="0"/>
                         </a:rPr>
-                        <a:t>role in the design</a:t>
+                        <a:t>anion vs. host</a:t>
                       </a:r>
                     </a:p>
                   </a:txBody>
@@ -20645,7 +20645,7 @@
                           <a:ea typeface="Calibri" panose="020F0502020204030204" pitchFamily="34" charset="0"/>
                           <a:cs typeface="Calibri" panose="020F0502020204030204" pitchFamily="34" charset="0"/>
                         </a:rPr>
-                        <a:t>strong M–O bonds</a:t>
+                        <a:t>O²⁻, smaller than S²⁻</a:t>
                       </a:r>
                     </a:p>
                   </a:txBody>
@@ -20983,7 +20983,7 @@
                           <a:ea typeface="Calibri" panose="020F0502020204030204" pitchFamily="34" charset="0"/>
                           <a:cs typeface="Calibri" panose="020F0502020204030204" pitchFamily="34" charset="0"/>
                         </a:rPr>
-                        <a:t>the host already has Cl</a:t>
+                        <a:t>Cl⁻, already in the host</a:t>
                       </a:r>
                     </a:p>
                   </a:txBody>
@@ -21321,128 +21321,7 @@
                           <a:ea typeface="Calibri" panose="020F0502020204030204" pitchFamily="34" charset="0"/>
                           <a:cs typeface="Calibri" panose="020F0502020204030204" pitchFamily="34" charset="0"/>
                         </a:rPr>
-                        <a:t>control</a:t>
-                      </a:r>
-                      <a:r>
-                        <a:rPr lang="ko-KR" altLang="en-US" sz="1300" b="0" kern="1200" dirty="0">
-                          <a:solidFill>
-                            <a:schemeClr val="bg1"/>
-                          </a:solidFill>
-                          <a:latin typeface="Calibri" panose="020F0502020204030204" pitchFamily="34" charset="0"/>
-                          <a:ea typeface="+mn-ea"/>
-                          <a:cs typeface="Calibri" panose="020F0502020204030204" pitchFamily="34" charset="0"/>
-                        </a:rPr>
-                        <a:t> </a:t>
-                      </a:r>
-                      <a:r>
-                        <a:rPr lang="en-US" altLang="ko-KR" sz="1300" b="0" kern="1200" dirty="0">
-                          <a:solidFill>
-                            <a:schemeClr val="bg1"/>
-                          </a:solidFill>
-                          <a:latin typeface="Calibri" panose="020F0502020204030204" pitchFamily="34" charset="0"/>
-                          <a:ea typeface="Calibri" panose="020F0502020204030204" pitchFamily="34" charset="0"/>
-                          <a:cs typeface="Calibri" panose="020F0502020204030204" pitchFamily="34" charset="0"/>
-                        </a:rPr>
-                        <a:t>— </a:t>
-                      </a:r>
-                      <a:r>
-                        <a:rPr lang="en-US" altLang="ko-KR" sz="1300" b="0" kern="1200" dirty="0" err="1">
-                          <a:solidFill>
-                            <a:schemeClr val="bg1"/>
-                          </a:solidFill>
-                          <a:latin typeface="Calibri" panose="020F0502020204030204" pitchFamily="34" charset="0"/>
-                          <a:ea typeface="Calibri" panose="020F0502020204030204" pitchFamily="34" charset="0"/>
-                          <a:cs typeface="Calibri" panose="020F0502020204030204" pitchFamily="34" charset="0"/>
-                        </a:rPr>
-                        <a:t>same</a:t>
-                      </a:r>
-                      <a:r>
-                        <a:rPr lang="ko-KR" altLang="en-US" sz="1300" b="0" kern="1200" dirty="0">
-                          <a:solidFill>
-                            <a:schemeClr val="bg1"/>
-                          </a:solidFill>
-                          <a:latin typeface="Calibri" panose="020F0502020204030204" pitchFamily="34" charset="0"/>
-                          <a:ea typeface="+mn-ea"/>
-                          <a:cs typeface="Calibri" panose="020F0502020204030204" pitchFamily="34" charset="0"/>
-                        </a:rPr>
-                        <a:t> </a:t>
-                      </a:r>
-                      <a:r>
-                        <a:rPr lang="en-US" altLang="ko-KR" sz="1300" b="0" kern="1200" dirty="0" err="1">
-                          <a:solidFill>
-                            <a:schemeClr val="bg1"/>
-                          </a:solidFill>
-                          <a:latin typeface="Calibri" panose="020F0502020204030204" pitchFamily="34" charset="0"/>
-                          <a:ea typeface="Calibri" panose="020F0502020204030204" pitchFamily="34" charset="0"/>
-                          <a:cs typeface="Calibri" panose="020F0502020204030204" pitchFamily="34" charset="0"/>
-                        </a:rPr>
-                        <a:t>anion</a:t>
-                      </a:r>
-                      <a:r>
-                        <a:rPr lang="ko-KR" altLang="en-US" sz="1300" b="0" kern="1200" dirty="0">
-                          <a:solidFill>
-                            <a:schemeClr val="bg1"/>
-                          </a:solidFill>
-                          <a:latin typeface="Calibri" panose="020F0502020204030204" pitchFamily="34" charset="0"/>
-                          <a:ea typeface="+mn-ea"/>
-                          <a:cs typeface="Calibri" panose="020F0502020204030204" pitchFamily="34" charset="0"/>
-                        </a:rPr>
-                        <a:t> </a:t>
-                      </a:r>
-                      <a:r>
-                        <a:rPr lang="en-US" altLang="ko-KR" sz="1300" b="0" kern="1200" dirty="0" err="1">
-                          <a:solidFill>
-                            <a:schemeClr val="bg1"/>
-                          </a:solidFill>
-                          <a:latin typeface="Calibri" panose="020F0502020204030204" pitchFamily="34" charset="0"/>
-                          <a:ea typeface="Calibri" panose="020F0502020204030204" pitchFamily="34" charset="0"/>
-                          <a:cs typeface="Calibri" panose="020F0502020204030204" pitchFamily="34" charset="0"/>
-                        </a:rPr>
-                        <a:t>as</a:t>
-                      </a:r>
-                      <a:r>
-                        <a:rPr lang="ko-KR" altLang="en-US" sz="1300" b="0" kern="1200" dirty="0">
-                          <a:solidFill>
-                            <a:schemeClr val="bg1"/>
-                          </a:solidFill>
-                          <a:latin typeface="Calibri" panose="020F0502020204030204" pitchFamily="34" charset="0"/>
-                          <a:ea typeface="+mn-ea"/>
-                          <a:cs typeface="Calibri" panose="020F0502020204030204" pitchFamily="34" charset="0"/>
-                        </a:rPr>
-                        <a:t> </a:t>
-                      </a:r>
-                      <a:r>
-                        <a:rPr lang="en-US" altLang="ko-KR" sz="1300" b="0" kern="1200" dirty="0" err="1">
-                          <a:solidFill>
-                            <a:schemeClr val="bg1"/>
-                          </a:solidFill>
-                          <a:latin typeface="Calibri" panose="020F0502020204030204" pitchFamily="34" charset="0"/>
-                          <a:ea typeface="Calibri" panose="020F0502020204030204" pitchFamily="34" charset="0"/>
-                          <a:cs typeface="Calibri" panose="020F0502020204030204" pitchFamily="34" charset="0"/>
-                        </a:rPr>
-                        <a:t>the</a:t>
-                      </a:r>
-                      <a:r>
-                        <a:rPr lang="ko-KR" altLang="en-US" sz="1300" b="0" kern="1200" dirty="0">
-                          <a:solidFill>
-                            <a:schemeClr val="bg1"/>
-                          </a:solidFill>
-                          <a:latin typeface="Calibri" panose="020F0502020204030204" pitchFamily="34" charset="0"/>
-                          <a:ea typeface="+mn-ea"/>
-                          <a:cs typeface="Calibri" panose="020F0502020204030204" pitchFamily="34" charset="0"/>
-                        </a:rPr>
-                        <a:t> </a:t>
-                      </a:r>
-                      <a:r>
-                        <a:rPr lang="en-US" altLang="ko-KR" sz="1300" b="0" kern="1200" dirty="0" err="1">
-                          <a:solidFill>
-                            <a:schemeClr val="bg1"/>
-                          </a:solidFill>
-                          <a:latin typeface="Calibri" panose="020F0502020204030204" pitchFamily="34" charset="0"/>
-                          <a:ea typeface="Calibri" panose="020F0502020204030204" pitchFamily="34" charset="0"/>
-                          <a:cs typeface="Calibri" panose="020F0502020204030204" pitchFamily="34" charset="0"/>
-                        </a:rPr>
-                        <a:t>host</a:t>
+                        <a:t>S²⁻, already in the host</a:t>
                       </a:r>
                       <a:endParaRPr lang="ko-KR" altLang="en-US" sz="1300" b="0" kern="1200" dirty="0">
                         <a:solidFill>
@@ -21810,73 +21689,7 @@
                           <a:ea typeface="Calibri" panose="020F0502020204030204" pitchFamily="34" charset="0"/>
                           <a:cs typeface="Calibri" panose="020F0502020204030204" pitchFamily="34" charset="0"/>
                         </a:rPr>
-                        <a:t>strongest</a:t>
-                      </a:r>
-                      <a:r>
-                        <a:rPr lang="ko-KR" altLang="en-US" sz="1300" b="0" kern="1200" dirty="0">
-                          <a:solidFill>
-                            <a:schemeClr val="bg1"/>
-                          </a:solidFill>
-                          <a:latin typeface="Calibri" panose="020F0502020204030204" pitchFamily="34" charset="0"/>
-                          <a:ea typeface="+mn-ea"/>
-                          <a:cs typeface="Calibri" panose="020F0502020204030204" pitchFamily="34" charset="0"/>
-                        </a:rPr>
-                        <a:t> </a:t>
-                      </a:r>
-                      <a:r>
-                        <a:rPr lang="en-US" altLang="ko-KR" sz="1300" b="0" kern="1200" dirty="0" err="1">
-                          <a:solidFill>
-                            <a:schemeClr val="bg1"/>
-                          </a:solidFill>
-                          <a:latin typeface="Calibri" panose="020F0502020204030204" pitchFamily="34" charset="0"/>
-                          <a:ea typeface="Calibri" panose="020F0502020204030204" pitchFamily="34" charset="0"/>
-                          <a:cs typeface="Calibri" panose="020F0502020204030204" pitchFamily="34" charset="0"/>
-                        </a:rPr>
-                        <a:t>bonds</a:t>
-                      </a:r>
-                      <a:r>
-                        <a:rPr lang="en-US" altLang="ko-KR" sz="1300" b="0" kern="1200" dirty="0">
-                          <a:solidFill>
-                            <a:schemeClr val="bg1"/>
-                          </a:solidFill>
-                          <a:latin typeface="Calibri" panose="020F0502020204030204" pitchFamily="34" charset="0"/>
-                          <a:ea typeface="Calibri" panose="020F0502020204030204" pitchFamily="34" charset="0"/>
-                          <a:cs typeface="Calibri" panose="020F0502020204030204" pitchFamily="34" charset="0"/>
-                        </a:rPr>
-                        <a:t>, </a:t>
-                      </a:r>
-                      <a:r>
-                        <a:rPr lang="en-US" altLang="ko-KR" sz="1300" b="0" kern="1200" dirty="0" err="1">
-                          <a:solidFill>
-                            <a:schemeClr val="bg1"/>
-                          </a:solidFill>
-                          <a:latin typeface="Calibri" panose="020F0502020204030204" pitchFamily="34" charset="0"/>
-                          <a:ea typeface="Calibri" panose="020F0502020204030204" pitchFamily="34" charset="0"/>
-                          <a:cs typeface="Calibri" panose="020F0502020204030204" pitchFamily="34" charset="0"/>
-                        </a:rPr>
-                        <a:t>mobility</a:t>
-                      </a:r>
-                      <a:r>
-                        <a:rPr lang="ko-KR" altLang="en-US" sz="1300" b="0" kern="1200" dirty="0">
-                          <a:solidFill>
-                            <a:schemeClr val="bg1"/>
-                          </a:solidFill>
-                          <a:latin typeface="Calibri" panose="020F0502020204030204" pitchFamily="34" charset="0"/>
-                          <a:ea typeface="+mn-ea"/>
-                          <a:cs typeface="Calibri" panose="020F0502020204030204" pitchFamily="34" charset="0"/>
-                        </a:rPr>
-                        <a:t> </a:t>
-                      </a:r>
-                      <a:r>
-                        <a:rPr lang="en-US" altLang="ko-KR" sz="1300" b="0" kern="1200" dirty="0" err="1">
-                          <a:solidFill>
-                            <a:schemeClr val="bg1"/>
-                          </a:solidFill>
-                          <a:latin typeface="Calibri" panose="020F0502020204030204" pitchFamily="34" charset="0"/>
-                          <a:ea typeface="Calibri" panose="020F0502020204030204" pitchFamily="34" charset="0"/>
-                          <a:cs typeface="Calibri" panose="020F0502020204030204" pitchFamily="34" charset="0"/>
-                        </a:rPr>
-                        <a:t>risk</a:t>
+                        <a:t>F⁻, smaller than Cl⁻</a:t>
                       </a:r>
                       <a:endParaRPr lang="ko-KR" altLang="en-US" sz="1300" b="0" kern="1200" dirty="0">
                         <a:solidFill>
@@ -22244,29 +22057,7 @@
                           <a:ea typeface="Calibri" panose="020F0502020204030204" pitchFamily="34" charset="0"/>
                           <a:cs typeface="Calibri" panose="020F0502020204030204" pitchFamily="34" charset="0"/>
                         </a:rPr>
-                        <a:t>control</a:t>
-                      </a:r>
-                      <a:r>
-                        <a:rPr lang="ko-KR" altLang="en-US" sz="1300" b="0" kern="1200" dirty="0">
-                          <a:solidFill>
-                            <a:schemeClr val="bg1"/>
-                          </a:solidFill>
-                          <a:latin typeface="Calibri" panose="020F0502020204030204" pitchFamily="34" charset="0"/>
-                          <a:ea typeface="+mn-ea"/>
-                          <a:cs typeface="Calibri" panose="020F0502020204030204" pitchFamily="34" charset="0"/>
-                        </a:rPr>
-                        <a:t> </a:t>
-                      </a:r>
-                      <a:r>
-                        <a:rPr lang="en-US" altLang="ko-KR" sz="1300" b="0" kern="1200" dirty="0">
-                          <a:solidFill>
-                            <a:schemeClr val="bg1"/>
-                          </a:solidFill>
-                          <a:latin typeface="Calibri" panose="020F0502020204030204" pitchFamily="34" charset="0"/>
-                          <a:ea typeface="Calibri" panose="020F0502020204030204" pitchFamily="34" charset="0"/>
-                          <a:cs typeface="Calibri" panose="020F0502020204030204" pitchFamily="34" charset="0"/>
-                        </a:rPr>
-                        <a:t>— larger halide</a:t>
+                        <a:t>Br⁻, larger than Cl⁻</a:t>
                       </a:r>
                     </a:p>
                   </a:txBody>
@@ -22604,29 +22395,7 @@
                           <a:ea typeface="Calibri" panose="020F0502020204030204" pitchFamily="34" charset="0"/>
                           <a:cs typeface="Calibri" panose="020F0502020204030204" pitchFamily="34" charset="0"/>
                         </a:rPr>
-                        <a:t>control</a:t>
-                      </a:r>
-                      <a:r>
-                        <a:rPr lang="ko-KR" altLang="en-US" sz="1300" b="0" kern="1200" dirty="0">
-                          <a:solidFill>
-                            <a:schemeClr val="bg1"/>
-                          </a:solidFill>
-                          <a:latin typeface="Calibri" panose="020F0502020204030204" pitchFamily="34" charset="0"/>
-                          <a:ea typeface="+mn-ea"/>
-                          <a:cs typeface="Calibri" panose="020F0502020204030204" pitchFamily="34" charset="0"/>
-                        </a:rPr>
-                        <a:t> </a:t>
-                      </a:r>
-                      <a:r>
-                        <a:rPr lang="en-US" altLang="ko-KR" sz="1300" b="0" kern="1200" dirty="0">
-                          <a:solidFill>
-                            <a:schemeClr val="bg1"/>
-                          </a:solidFill>
-                          <a:latin typeface="Calibri" panose="020F0502020204030204" pitchFamily="34" charset="0"/>
-                          <a:ea typeface="Calibri" panose="020F0502020204030204" pitchFamily="34" charset="0"/>
-                          <a:cs typeface="Calibri" panose="020F0502020204030204" pitchFamily="34" charset="0"/>
-                        </a:rPr>
-                        <a:t>— higher anion charge</a:t>
+                        <a:t>N³⁻, higher charge than S²⁻</a:t>
                       </a:r>
                     </a:p>
                   </a:txBody>
@@ -23041,29 +22810,7 @@
                           <a:ea typeface="Calibri" panose="020F0502020204030204" pitchFamily="34" charset="0"/>
                           <a:cs typeface="Calibri" panose="020F0502020204030204" pitchFamily="34" charset="0"/>
                         </a:rPr>
-                        <a:t>control</a:t>
-                      </a:r>
-                      <a:r>
-                        <a:rPr lang="ko-KR" altLang="en-US" sz="1300" b="0" kern="1200" dirty="0">
-                          <a:solidFill>
-                            <a:schemeClr val="bg1"/>
-                          </a:solidFill>
-                          <a:latin typeface="Calibri" panose="020F0502020204030204" pitchFamily="34" charset="0"/>
-                          <a:ea typeface="+mn-ea"/>
-                          <a:cs typeface="Calibri" panose="020F0502020204030204" pitchFamily="34" charset="0"/>
-                        </a:rPr>
-                        <a:t> </a:t>
-                      </a:r>
-                      <a:r>
-                        <a:rPr lang="en-US" altLang="ko-KR" sz="1300" b="0" kern="1200" dirty="0">
-                          <a:solidFill>
-                            <a:schemeClr val="bg1"/>
-                          </a:solidFill>
-                          <a:latin typeface="Calibri" panose="020F0502020204030204" pitchFamily="34" charset="0"/>
-                          <a:ea typeface="Calibri" panose="020F0502020204030204" pitchFamily="34" charset="0"/>
-                          <a:cs typeface="Calibri" panose="020F0502020204030204" pitchFamily="34" charset="0"/>
-                        </a:rPr>
-                        <a:t>— largest halide</a:t>
+                        <a:t>I⁻, much larger than Cl⁻</a:t>
                       </a:r>
                     </a:p>
                   </a:txBody>
@@ -23375,7 +23122,7 @@
                 <a:ea typeface="-윤고딕340" pitchFamily="18" charset="-127"/>
                 <a:cs typeface="Calibri" panose="020F0502020204030204" pitchFamily="34" charset="0"/>
               </a:rPr>
-              <a:t>Candidate set: 91 precursor compounds in seven anion families</a:t>
+              <a:t>91 precursors in seven anion families</a:t>
             </a:r>
           </a:p>
           <a:p>
@@ -23400,7 +23147,29 @@
                 <a:ea typeface="-윤고딕340" pitchFamily="18" charset="-127"/>
                 <a:cs typeface="Calibri" panose="020F0502020204030204" pitchFamily="34" charset="0"/>
               </a:rPr>
-              <a:t>Cations +1 to +6, anions O²⁻ to I⁻; only existing compounds are used.</a:t>
+              <a:t>Every precursor is an </a:t>
+            </a:r>
+            <a:r>
+              <a:rPr kumimoji="1" lang="en-US" altLang="ko-KR" sz="1500" dirty="0">
+                <a:solidFill>
+                  <a:srgbClr val="0070C0"/>
+                </a:solidFill>
+                <a:latin typeface="Calibri" panose="020F0502020204030204" pitchFamily="34" charset="0"/>
+                <a:ea typeface="-윤고딕340" pitchFamily="18" charset="-127"/>
+                <a:cs typeface="Calibri" panose="020F0502020204030204" pitchFamily="34" charset="0"/>
+              </a:rPr>
+              <a:t>existing compound</a:t>
+            </a:r>
+            <a:r>
+              <a:rPr kumimoji="1" lang="en-US" altLang="ko-KR" sz="1500" dirty="0">
+                <a:solidFill>
+                  <a:schemeClr val="bg1"/>
+                </a:solidFill>
+                <a:latin typeface="Calibri" panose="020F0502020204030204" pitchFamily="34" charset="0"/>
+                <a:ea typeface="-윤고딕340" pitchFamily="18" charset="-127"/>
+                <a:cs typeface="Calibri" panose="020F0502020204030204" pitchFamily="34" charset="0"/>
+              </a:rPr>
+              <a:t>, with a cation from +1 to +6.</a:t>
             </a:r>
           </a:p>
           <a:p>
@@ -23419,13 +23188,24 @@
             <a:r>
               <a:rPr kumimoji="1" lang="en-US" altLang="ko-KR" sz="1500" dirty="0">
                 <a:solidFill>
+                  <a:srgbClr val="0070C0"/>
+                </a:solidFill>
+                <a:latin typeface="Calibri" panose="020F0502020204030204" pitchFamily="34" charset="0"/>
+                <a:ea typeface="-윤고딕340" pitchFamily="18" charset="-127"/>
+                <a:cs typeface="Calibri" panose="020F0502020204030204" pitchFamily="34" charset="0"/>
+              </a:rPr>
+              <a:t>Al, Li, and Mg</a:t>
+            </a:r>
+            <a:r>
+              <a:rPr kumimoji="1" lang="en-US" altLang="ko-KR" sz="1500" dirty="0">
+                <a:solidFill>
                   <a:schemeClr val="bg1"/>
                 </a:solidFill>
                 <a:latin typeface="Calibri" panose="020F0502020204030204" pitchFamily="34" charset="0"/>
                 <a:ea typeface="-윤고딕340" pitchFamily="18" charset="-127"/>
                 <a:cs typeface="Calibri" panose="020F0502020204030204" pitchFamily="34" charset="0"/>
               </a:rPr>
-              <a:t>All 91 relaxed — As₂S₃ and AlI₃ were completed in an August re-run.</a:t>
+              <a:t> appear in all seven families, so their partner anions can be compared.</a:t>
             </a:r>
           </a:p>
         </p:txBody>

</xml_diff>

<commit_message>
Seminar decks: section titles follow the 08-18 order
User 10-13: "Introduction, then Results & Discussion is the right
order." The 08-18 deck titles slides 3-7 Introduction and 8-18
Results & Discussion; our decks had introduced "Approach" (p06-p10)
and "Progress" (p11-p13). All fourteen header/fresh calls now set
"Results & Discussion"; Plan (p14) and Summary (p15) stay. Both decks
rebuilt and validated, p06-p13 renders and the contact sheet updated,
and CLAUDE.md records the rule.

Co-Authored-By: Claude Opus 5.5 <noreply@anthropic.com>
Claude-Session: https://claude.ai/code/session_01QtbBQvJTvwH5CtkzA6CTzs
</commit_message>
<xml_diff>
--- a/kb/seminars/Research_Seminar_2026_10_13_cascade_progress.pptx
+++ b/kb/seminars/Research_Seminar_2026_10_13_cascade_progress.pptx
@@ -3619,7 +3619,7 @@
                 <a:ea typeface="굴림" pitchFamily="50" charset="-127"/>
                 <a:cs typeface="Arial" panose="020B0604020202020204" pitchFamily="34" charset="0"/>
               </a:rPr>
-              <a:t>Approach</a:t>
+              <a:t>Results &amp; Discussion</a:t>
             </a:r>
           </a:p>
         </p:txBody>
@@ -4344,7 +4344,7 @@
                 <a:ea typeface="굴림" pitchFamily="50" charset="-127"/>
                 <a:cs typeface="Arial" panose="020B0604020202020204" pitchFamily="34" charset="0"/>
               </a:rPr>
-              <a:t>Approach</a:t>
+              <a:t>Results &amp; Discussion</a:t>
             </a:r>
           </a:p>
         </p:txBody>
@@ -8037,7 +8037,7 @@
                 <a:ea typeface="굴림" pitchFamily="50" charset="-127"/>
                 <a:cs typeface="Arial" panose="020B0604020202020204" pitchFamily="34" charset="0"/>
               </a:rPr>
-              <a:t>Approach</a:t>
+              <a:t>Results &amp; Discussion</a:t>
             </a:r>
           </a:p>
         </p:txBody>
@@ -10921,7 +10921,7 @@
                 <a:ea typeface="굴림" pitchFamily="50" charset="-127"/>
                 <a:cs typeface="Arial" panose="020B0604020202020204" pitchFamily="34" charset="0"/>
               </a:rPr>
-              <a:t>Approach</a:t>
+              <a:t>Results &amp; Discussion</a:t>
             </a:r>
           </a:p>
         </p:txBody>
@@ -11850,7 +11850,7 @@
                 <a:ea typeface="굴림" pitchFamily="50" charset="-127"/>
                 <a:cs typeface="Arial" panose="020B0604020202020204" pitchFamily="34" charset="0"/>
               </a:rPr>
-              <a:t>Progress</a:t>
+              <a:t>Results &amp; Discussion</a:t>
             </a:r>
           </a:p>
         </p:txBody>
@@ -12967,7 +12967,7 @@
                 <a:ea typeface="굴림" pitchFamily="50" charset="-127"/>
                 <a:cs typeface="Arial" panose="020B0604020202020204" pitchFamily="34" charset="0"/>
               </a:rPr>
-              <a:t>Progress</a:t>
+              <a:t>Results &amp; Discussion</a:t>
             </a:r>
           </a:p>
         </p:txBody>
@@ -14544,7 +14544,7 @@
                 <a:ea typeface="굴림" pitchFamily="50" charset="-127"/>
                 <a:cs typeface="Arial" panose="020B0604020202020204" pitchFamily="34" charset="0"/>
               </a:rPr>
-              <a:t>Progress</a:t>
+              <a:t>Results &amp; Discussion</a:t>
             </a:r>
           </a:p>
         </p:txBody>
@@ -20139,7 +20139,7 @@
                 <a:ea typeface="굴림" pitchFamily="50" charset="-127"/>
                 <a:cs typeface="Arial" panose="020B0604020202020204" pitchFamily="34" charset="0"/>
               </a:rPr>
-              <a:t>Approach</a:t>
+              <a:t>Results &amp; Discussion</a:t>
             </a:r>
           </a:p>
         </p:txBody>

</xml_diff>